<commit_message>
Replace churn_analysis with Telco dataset; honest 0.845 ROC-AUC baseline
Replace the synthetic customers.csv (which produced a perfect ROC-AUC 1.0 — honest but a weak showcase) with the Kaggle Telco Customer Churn dataset (7,043 rows, 21 columns, ~977KB). Real-world data: 26.5% churn rate, TotalCharges stored as VARCHAR due to 11 blank rows (engine reports this honestly). Leakage sentinel clean (leakage_warnings:[]). Baseline LogisticRegression: ROC-AUC 0.845, recall 0.546, precision 0.661 — a credible, imperfect real result (5,282 train / 1,761 test, stratified, seed 42). Target selection: Churn is first binary_target in column order (disclosed deterministic rule; 7 binary candidates listed). Runner updated with PaySim-style target guard asserting Churn is first before proceeding. Step 21 report generated. Preserve synthetic package to examples/historical/churn_analysis_pre_v1/.
</commit_message>
<xml_diff>
--- a/examples/churn_analysis/output/final/delivery_package.pptx
+++ b/examples/churn_analysis/output/final/delivery_package.pptx
@@ -196,13 +196,13 @@
                 <c:formatCode>General</c:formatCode>
                 <c:ptCount val="3"/>
                 <c:pt idx="0">
-                  <c:v>1</c:v>
+                  <c:v>0.8455</c:v>
                 </c:pt>
                 <c:pt idx="1">
-                  <c:v>1</c:v>
+                  <c:v>0.5979</c:v>
                 </c:pt>
                 <c:pt idx="2">
-                  <c:v>1</c:v>
+                  <c:v>0.8052</c:v>
                 </c:pt>
               </c:numCache>
             </c:numRef>
@@ -1753,7 +1753,7 @@
                   <a:srgbClr val="9BB3CC"/>
                 </a:solidFill>
               </a:rPr>
-              <a:t>Source: customers.csv</a:t>
+              <a:t>Source: WA_Fn-UseC_-Telco-Customer-Churn.csv</a:t>
             </a:r>
             <a:endParaRPr lang="en-US" sz="1400" dirty="0"/>
           </a:p>
@@ -1927,7 +1927,7 @@
                   <a:srgbClr val="0A7E8C"/>
                 </a:solidFill>
               </a:rPr>
-              <a:t>400</a:t>
+              <a:t>7,043</a:t>
             </a:r>
             <a:endParaRPr lang="en-US" sz="3200" dirty="0"/>
           </a:p>
@@ -2033,7 +2033,7 @@
                   <a:srgbClr val="0A7E8C"/>
                 </a:solidFill>
               </a:rPr>
-              <a:t>5</a:t>
+              <a:t>21</a:t>
             </a:r>
             <a:endParaRPr lang="en-US" sz="3200" dirty="0"/>
           </a:p>
@@ -2845,7 +2845,7 @@
                             <a:srgbClr val="2C3E50"/>
                           </a:solidFill>
                         </a:rPr>
-                        <a:t>customer_id</a:t>
+                        <a:t>customerID</a:t>
                       </a:r>
                       <a:endParaRPr lang="en-US" sz="1100" dirty="0"/>
                     </a:p>
@@ -2967,7 +2967,7 @@
                             <a:srgbClr val="2C3E50"/>
                           </a:solidFill>
                         </a:rPr>
-                        <a:t>400</a:t>
+                        <a:t>7,043</a:t>
                       </a:r>
                       <a:endParaRPr lang="en-US" sz="1100" dirty="0"/>
                     </a:p>
@@ -3089,7 +3089,7 @@
                             <a:srgbClr val="2C3E50"/>
                           </a:solidFill>
                         </a:rPr>
-                        <a:t>400</a:t>
+                        <a:t>7,043</a:t>
                       </a:r>
                       <a:endParaRPr lang="en-US" sz="1100" dirty="0"/>
                     </a:p>
@@ -3185,7 +3185,7 @@
                             <a:srgbClr val="2C3E50"/>
                           </a:solidFill>
                         </a:rPr>
-                        <a:t>churned</a:t>
+                        <a:t>gender</a:t>
                       </a:r>
                       <a:endParaRPr lang="en-US" sz="1100" dirty="0"/>
                     </a:p>
@@ -3246,7 +3246,7 @@
                             <a:srgbClr val="2C3E50"/>
                           </a:solidFill>
                         </a:rPr>
-                        <a:t>BOOLEAN</a:t>
+                        <a:t>VARCHAR</a:t>
                       </a:r>
                       <a:endParaRPr lang="en-US" sz="1100" dirty="0"/>
                     </a:p>
@@ -3307,7 +3307,7 @@
                             <a:srgbClr val="2C3E50"/>
                           </a:solidFill>
                         </a:rPr>
-                        <a:t>400</a:t>
+                        <a:t>7,043</a:t>
                       </a:r>
                       <a:endParaRPr lang="en-US" sz="1100" dirty="0"/>
                     </a:p>
@@ -3525,7 +3525,7 @@
                             <a:srgbClr val="2C3E50"/>
                           </a:solidFill>
                         </a:rPr>
-                        <a:t>tenure_months</a:t>
+                        <a:t>SeniorCitizen</a:t>
                       </a:r>
                       <a:endParaRPr lang="en-US" sz="1100" dirty="0"/>
                     </a:p>
@@ -3647,7 +3647,7 @@
                             <a:srgbClr val="2C3E50"/>
                           </a:solidFill>
                         </a:rPr>
-                        <a:t>400</a:t>
+                        <a:t>7,043</a:t>
                       </a:r>
                       <a:endParaRPr lang="en-US" sz="1100" dirty="0"/>
                     </a:p>
@@ -3769,7 +3769,7 @@
                             <a:srgbClr val="2C3E50"/>
                           </a:solidFill>
                         </a:rPr>
-                        <a:t>60</a:t>
+                        <a:t>2</a:t>
                       </a:r>
                       <a:endParaRPr lang="en-US" sz="1100" dirty="0"/>
                     </a:p>
@@ -3865,7 +3865,7 @@
                             <a:srgbClr val="2C3E50"/>
                           </a:solidFill>
                         </a:rPr>
-                        <a:t>plan_type</a:t>
+                        <a:t>Partner</a:t>
                       </a:r>
                       <a:endParaRPr lang="en-US" sz="1100" dirty="0"/>
                     </a:p>
@@ -3926,7 +3926,7 @@
                             <a:srgbClr val="2C3E50"/>
                           </a:solidFill>
                         </a:rPr>
-                        <a:t>VARCHAR</a:t>
+                        <a:t>BOOLEAN</a:t>
                       </a:r>
                       <a:endParaRPr lang="en-US" sz="1100" dirty="0"/>
                     </a:p>
@@ -3987,7 +3987,7 @@
                             <a:srgbClr val="2C3E50"/>
                           </a:solidFill>
                         </a:rPr>
-                        <a:t>400</a:t>
+                        <a:t>7,043</a:t>
                       </a:r>
                       <a:endParaRPr lang="en-US" sz="1100" dirty="0"/>
                     </a:p>
@@ -4109,7 +4109,7 @@
                             <a:srgbClr val="2C3E50"/>
                           </a:solidFill>
                         </a:rPr>
-                        <a:t>3</a:t>
+                        <a:t>2</a:t>
                       </a:r>
                       <a:endParaRPr lang="en-US" sz="1100" dirty="0"/>
                     </a:p>
@@ -4205,7 +4205,7 @@
                             <a:srgbClr val="2C3E50"/>
                           </a:solidFill>
                         </a:rPr>
-                        <a:t>monthly_spend</a:t>
+                        <a:t>Dependents</a:t>
                       </a:r>
                       <a:endParaRPr lang="en-US" sz="1100" dirty="0"/>
                     </a:p>
@@ -4266,7 +4266,7 @@
                             <a:srgbClr val="2C3E50"/>
                           </a:solidFill>
                         </a:rPr>
-                        <a:t>DOUBLE</a:t>
+                        <a:t>BOOLEAN</a:t>
                       </a:r>
                       <a:endParaRPr lang="en-US" sz="1100" dirty="0"/>
                     </a:p>
@@ -4327,7 +4327,7 @@
                             <a:srgbClr val="2C3E50"/>
                           </a:solidFill>
                         </a:rPr>
-                        <a:t>400</a:t>
+                        <a:t>7,043</a:t>
                       </a:r>
                       <a:endParaRPr lang="en-US" sz="1100" dirty="0"/>
                     </a:p>
@@ -4449,7 +4449,7 @@
                             <a:srgbClr val="2C3E50"/>
                           </a:solidFill>
                         </a:rPr>
-                        <a:t>50</a:t>
+                        <a:t>2</a:t>
                       </a:r>
                       <a:endParaRPr lang="en-US" sz="1100" dirty="0"/>
                     </a:p>
@@ -4501,6 +4501,382 @@
           </a:graphicData>
         </a:graphic>
       </p:graphicFrame>
+      <p:graphicFrame>
+        <p:nvGraphicFramePr>
+          <p:cNvPr id="22" name="Table 6"/>
+          <p:cNvGraphicFramePr>
+            <a:graphicFrameLocks noGrp="1"/>
+          </p:cNvGraphicFramePr>
+          <p:nvPr>
+            <p:extLst>
+              <p:ext uri="{D42A27DB-BD31-4B8C-83A1-F6EECF244321}">
+                <p14:modId xmlns:p14="http://schemas.microsoft.com/office/powerpoint/2010/main" val="1579011935"/>
+              </p:ext>
+            </p:extLst>
+          </p:nvPr>
+        </p:nvGraphicFramePr>
+        <p:xfrm>
+          <a:off x="365760" y="3337560"/>
+          <a:ext cx="11430000" cy="365760"/>
+        </p:xfrm>
+        <a:graphic>
+          <a:graphicData uri="http://schemas.openxmlformats.org/drawingml/2006/table">
+            <a:tbl>
+              <a:tblPr/>
+              <a:tblGrid>
+                <a:gridCol w="2743200"/>
+                <a:gridCol w="1828800"/>
+                <a:gridCol w="1828800"/>
+                <a:gridCol w="1828800"/>
+                <a:gridCol w="2743200"/>
+              </a:tblGrid>
+              <a:tr h="365760">
+                <a:tc>
+                  <a:txBody>
+                    <a:bodyPr/>
+                    <a:lstStyle/>
+                    <a:p>
+                      <a:pPr indent="0" marL="0">
+                        <a:buNone/>
+                      </a:pPr>
+                      <a:r>
+                        <a:rPr lang="en-US" sz="1100" dirty="0">
+                          <a:solidFill>
+                            <a:srgbClr val="2C3E50"/>
+                          </a:solidFill>
+                        </a:rPr>
+                        <a:t>tenure</a:t>
+                      </a:r>
+                      <a:endParaRPr lang="en-US" sz="1100" dirty="0"/>
+                    </a:p>
+                  </a:txBody>
+                  <a:tcPr marL="91440" marR="91440" marT="45720" marB="45720">
+                    <a:lnL w="6350" cap="flat" cmpd="sng" algn="ctr">
+                      <a:solidFill>
+                        <a:srgbClr val="E2E8F0"/>
+                      </a:solidFill>
+                      <a:prstDash val="solid"/>
+                      <a:round/>
+                      <a:headEnd type="none" w="med" len="med"/>
+                      <a:tailEnd type="none" w="med" len="med"/>
+                    </a:lnL>
+                    <a:lnR w="6350" cap="flat" cmpd="sng" algn="ctr">
+                      <a:solidFill>
+                        <a:srgbClr val="E2E8F0"/>
+                      </a:solidFill>
+                      <a:prstDash val="solid"/>
+                      <a:round/>
+                      <a:headEnd type="none" w="med" len="med"/>
+                      <a:tailEnd type="none" w="med" len="med"/>
+                    </a:lnR>
+                    <a:lnT w="6350" cap="flat" cmpd="sng" algn="ctr">
+                      <a:solidFill>
+                        <a:srgbClr val="E2E8F0"/>
+                      </a:solidFill>
+                      <a:prstDash val="solid"/>
+                      <a:round/>
+                      <a:headEnd type="none" w="med" len="med"/>
+                      <a:tailEnd type="none" w="med" len="med"/>
+                    </a:lnT>
+                    <a:lnB w="6350" cap="flat" cmpd="sng" algn="ctr">
+                      <a:solidFill>
+                        <a:srgbClr val="E2E8F0"/>
+                      </a:solidFill>
+                      <a:prstDash val="solid"/>
+                      <a:round/>
+                      <a:headEnd type="none" w="med" len="med"/>
+                      <a:tailEnd type="none" w="med" len="med"/>
+                    </a:lnB>
+                    <a:solidFill>
+                      <a:srgbClr val="FFFFFF"/>
+                    </a:solidFill>
+                  </a:tcPr>
+                </a:tc>
+                <a:tc>
+                  <a:txBody>
+                    <a:bodyPr/>
+                    <a:lstStyle/>
+                    <a:p>
+                      <a:pPr indent="0" marL="0">
+                        <a:buNone/>
+                      </a:pPr>
+                      <a:r>
+                        <a:rPr lang="en-US" sz="1100" dirty="0">
+                          <a:solidFill>
+                            <a:srgbClr val="2C3E50"/>
+                          </a:solidFill>
+                        </a:rPr>
+                        <a:t>BIGINT</a:t>
+                      </a:r>
+                      <a:endParaRPr lang="en-US" sz="1100" dirty="0"/>
+                    </a:p>
+                  </a:txBody>
+                  <a:tcPr marL="91440" marR="91440" marT="45720" marB="45720">
+                    <a:lnL w="6350" cap="flat" cmpd="sng" algn="ctr">
+                      <a:solidFill>
+                        <a:srgbClr val="E2E8F0"/>
+                      </a:solidFill>
+                      <a:prstDash val="solid"/>
+                      <a:round/>
+                      <a:headEnd type="none" w="med" len="med"/>
+                      <a:tailEnd type="none" w="med" len="med"/>
+                    </a:lnL>
+                    <a:lnR w="6350" cap="flat" cmpd="sng" algn="ctr">
+                      <a:solidFill>
+                        <a:srgbClr val="E2E8F0"/>
+                      </a:solidFill>
+                      <a:prstDash val="solid"/>
+                      <a:round/>
+                      <a:headEnd type="none" w="med" len="med"/>
+                      <a:tailEnd type="none" w="med" len="med"/>
+                    </a:lnR>
+                    <a:lnT w="6350" cap="flat" cmpd="sng" algn="ctr">
+                      <a:solidFill>
+                        <a:srgbClr val="E2E8F0"/>
+                      </a:solidFill>
+                      <a:prstDash val="solid"/>
+                      <a:round/>
+                      <a:headEnd type="none" w="med" len="med"/>
+                      <a:tailEnd type="none" w="med" len="med"/>
+                    </a:lnT>
+                    <a:lnB w="6350" cap="flat" cmpd="sng" algn="ctr">
+                      <a:solidFill>
+                        <a:srgbClr val="E2E8F0"/>
+                      </a:solidFill>
+                      <a:prstDash val="solid"/>
+                      <a:round/>
+                      <a:headEnd type="none" w="med" len="med"/>
+                      <a:tailEnd type="none" w="med" len="med"/>
+                    </a:lnB>
+                    <a:solidFill>
+                      <a:srgbClr val="FFFFFF"/>
+                    </a:solidFill>
+                  </a:tcPr>
+                </a:tc>
+                <a:tc>
+                  <a:txBody>
+                    <a:bodyPr/>
+                    <a:lstStyle/>
+                    <a:p>
+                      <a:pPr algn="r" indent="0" marL="0">
+                        <a:buNone/>
+                      </a:pPr>
+                      <a:r>
+                        <a:rPr lang="en-US" sz="1100" dirty="0">
+                          <a:solidFill>
+                            <a:srgbClr val="2C3E50"/>
+                          </a:solidFill>
+                        </a:rPr>
+                        <a:t>7,043</a:t>
+                      </a:r>
+                      <a:endParaRPr lang="en-US" sz="1100" dirty="0"/>
+                    </a:p>
+                  </a:txBody>
+                  <a:tcPr marL="91440" marR="91440" marT="45720" marB="45720">
+                    <a:lnL w="6350" cap="flat" cmpd="sng" algn="ctr">
+                      <a:solidFill>
+                        <a:srgbClr val="E2E8F0"/>
+                      </a:solidFill>
+                      <a:prstDash val="solid"/>
+                      <a:round/>
+                      <a:headEnd type="none" w="med" len="med"/>
+                      <a:tailEnd type="none" w="med" len="med"/>
+                    </a:lnL>
+                    <a:lnR w="6350" cap="flat" cmpd="sng" algn="ctr">
+                      <a:solidFill>
+                        <a:srgbClr val="E2E8F0"/>
+                      </a:solidFill>
+                      <a:prstDash val="solid"/>
+                      <a:round/>
+                      <a:headEnd type="none" w="med" len="med"/>
+                      <a:tailEnd type="none" w="med" len="med"/>
+                    </a:lnR>
+                    <a:lnT w="6350" cap="flat" cmpd="sng" algn="ctr">
+                      <a:solidFill>
+                        <a:srgbClr val="E2E8F0"/>
+                      </a:solidFill>
+                      <a:prstDash val="solid"/>
+                      <a:round/>
+                      <a:headEnd type="none" w="med" len="med"/>
+                      <a:tailEnd type="none" w="med" len="med"/>
+                    </a:lnT>
+                    <a:lnB w="6350" cap="flat" cmpd="sng" algn="ctr">
+                      <a:solidFill>
+                        <a:srgbClr val="E2E8F0"/>
+                      </a:solidFill>
+                      <a:prstDash val="solid"/>
+                      <a:round/>
+                      <a:headEnd type="none" w="med" len="med"/>
+                      <a:tailEnd type="none" w="med" len="med"/>
+                    </a:lnB>
+                    <a:solidFill>
+                      <a:srgbClr val="FFFFFF"/>
+                    </a:solidFill>
+                  </a:tcPr>
+                </a:tc>
+                <a:tc>
+                  <a:txBody>
+                    <a:bodyPr/>
+                    <a:lstStyle/>
+                    <a:p>
+                      <a:pPr algn="r" indent="0" marL="0">
+                        <a:buNone/>
+                      </a:pPr>
+                      <a:r>
+                        <a:rPr lang="en-US" sz="1100" dirty="0">
+                          <a:solidFill>
+                            <a:srgbClr val="2C3E50"/>
+                          </a:solidFill>
+                        </a:rPr>
+                        <a:t>0.0%</a:t>
+                      </a:r>
+                      <a:endParaRPr lang="en-US" sz="1100" dirty="0"/>
+                    </a:p>
+                  </a:txBody>
+                  <a:tcPr marL="91440" marR="91440" marT="45720" marB="45720">
+                    <a:lnL w="6350" cap="flat" cmpd="sng" algn="ctr">
+                      <a:solidFill>
+                        <a:srgbClr val="E2E8F0"/>
+                      </a:solidFill>
+                      <a:prstDash val="solid"/>
+                      <a:round/>
+                      <a:headEnd type="none" w="med" len="med"/>
+                      <a:tailEnd type="none" w="med" len="med"/>
+                    </a:lnL>
+                    <a:lnR w="6350" cap="flat" cmpd="sng" algn="ctr">
+                      <a:solidFill>
+                        <a:srgbClr val="E2E8F0"/>
+                      </a:solidFill>
+                      <a:prstDash val="solid"/>
+                      <a:round/>
+                      <a:headEnd type="none" w="med" len="med"/>
+                      <a:tailEnd type="none" w="med" len="med"/>
+                    </a:lnR>
+                    <a:lnT w="6350" cap="flat" cmpd="sng" algn="ctr">
+                      <a:solidFill>
+                        <a:srgbClr val="E2E8F0"/>
+                      </a:solidFill>
+                      <a:prstDash val="solid"/>
+                      <a:round/>
+                      <a:headEnd type="none" w="med" len="med"/>
+                      <a:tailEnd type="none" w="med" len="med"/>
+                    </a:lnT>
+                    <a:lnB w="6350" cap="flat" cmpd="sng" algn="ctr">
+                      <a:solidFill>
+                        <a:srgbClr val="E2E8F0"/>
+                      </a:solidFill>
+                      <a:prstDash val="solid"/>
+                      <a:round/>
+                      <a:headEnd type="none" w="med" len="med"/>
+                      <a:tailEnd type="none" w="med" len="med"/>
+                    </a:lnB>
+                    <a:solidFill>
+                      <a:srgbClr val="FFFFFF"/>
+                    </a:solidFill>
+                  </a:tcPr>
+                </a:tc>
+                <a:tc>
+                  <a:txBody>
+                    <a:bodyPr/>
+                    <a:lstStyle/>
+                    <a:p>
+                      <a:pPr algn="r" indent="0" marL="0">
+                        <a:buNone/>
+                      </a:pPr>
+                      <a:r>
+                        <a:rPr lang="en-US" sz="1100" dirty="0">
+                          <a:solidFill>
+                            <a:srgbClr val="2C3E50"/>
+                          </a:solidFill>
+                        </a:rPr>
+                        <a:t>73</a:t>
+                      </a:r>
+                      <a:endParaRPr lang="en-US" sz="1100" dirty="0"/>
+                    </a:p>
+                  </a:txBody>
+                  <a:tcPr marL="91440" marR="91440" marT="45720" marB="45720">
+                    <a:lnL w="6350" cap="flat" cmpd="sng" algn="ctr">
+                      <a:solidFill>
+                        <a:srgbClr val="E2E8F0"/>
+                      </a:solidFill>
+                      <a:prstDash val="solid"/>
+                      <a:round/>
+                      <a:headEnd type="none" w="med" len="med"/>
+                      <a:tailEnd type="none" w="med" len="med"/>
+                    </a:lnL>
+                    <a:lnR w="6350" cap="flat" cmpd="sng" algn="ctr">
+                      <a:solidFill>
+                        <a:srgbClr val="E2E8F0"/>
+                      </a:solidFill>
+                      <a:prstDash val="solid"/>
+                      <a:round/>
+                      <a:headEnd type="none" w="med" len="med"/>
+                      <a:tailEnd type="none" w="med" len="med"/>
+                    </a:lnR>
+                    <a:lnT w="6350" cap="flat" cmpd="sng" algn="ctr">
+                      <a:solidFill>
+                        <a:srgbClr val="E2E8F0"/>
+                      </a:solidFill>
+                      <a:prstDash val="solid"/>
+                      <a:round/>
+                      <a:headEnd type="none" w="med" len="med"/>
+                      <a:tailEnd type="none" w="med" len="med"/>
+                    </a:lnT>
+                    <a:lnB w="6350" cap="flat" cmpd="sng" algn="ctr">
+                      <a:solidFill>
+                        <a:srgbClr val="E2E8F0"/>
+                      </a:solidFill>
+                      <a:prstDash val="solid"/>
+                      <a:round/>
+                      <a:headEnd type="none" w="med" len="med"/>
+                      <a:tailEnd type="none" w="med" len="med"/>
+                    </a:lnB>
+                    <a:solidFill>
+                      <a:srgbClr val="FFFFFF"/>
+                    </a:solidFill>
+                  </a:tcPr>
+                </a:tc>
+              </a:tr>
+            </a:tbl>
+          </a:graphicData>
+        </a:graphic>
+      </p:graphicFrame>
+      <p:sp>
+        <p:nvSpPr>
+          <p:cNvPr id="10" name="Text 1"/>
+          <p:cNvSpPr/>
+          <p:nvPr/>
+        </p:nvSpPr>
+        <p:spPr>
+          <a:xfrm>
+            <a:off x="365760" y="3749040"/>
+            <a:ext cx="11430000" cy="320040"/>
+          </a:xfrm>
+          <a:prstGeom prst="rect">
+            <a:avLst/>
+          </a:prstGeom>
+          <a:noFill/>
+          <a:ln/>
+        </p:spPr>
+        <p:txBody>
+          <a:bodyPr wrap="square" rtlCol="0" anchor="ctr"/>
+          <a:lstStyle/>
+          <a:p>
+            <a:pPr indent="0" marL="0">
+              <a:buNone/>
+            </a:pPr>
+            <a:r>
+              <a:rPr lang="en-US" sz="1100" i="1" dirty="0">
+                <a:solidFill>
+                  <a:srgbClr val="6B8AAD"/>
+                </a:solidFill>
+              </a:rPr>
+              <a:t>+ 15 more column(s) - see narrative report</a:t>
+            </a:r>
+            <a:endParaRPr lang="en-US" sz="1100" dirty="0"/>
+          </a:p>
+        </p:txBody>
+      </p:sp>
     </p:spTree>
   </p:cSld>
   <p:clrMapOvr>
@@ -4879,7 +5255,7 @@
                   <a:srgbClr val="2C3E50"/>
                 </a:solidFill>
               </a:rPr>
-              <a:t>Target: churned  |  Train: 300 rows  |  Test: 100 rows</a:t>
+              <a:t>Target: Churn  |  Train: 5282 rows  |  Test: 1761 rows</a:t>
             </a:r>
             <a:endParaRPr lang="en-US" sz="1300" dirty="0"/>
           </a:p>
@@ -5150,7 +5526,7 @@
                 <a:ea typeface="Courier New" pitchFamily="34" charset="-122"/>
                 <a:cs typeface="Courier New" pitchFamily="34" charset="-120"/>
               </a:rPr>
-              <a:t>dq_profile findings:   4fcc9974835b83c035bfda05...</a:t>
+              <a:t>dq_profile findings:   851b1ea2b88e9cd8c649a7f4...</a:t>
             </a:r>
             <a:endParaRPr lang="en-US" sz="1300" dirty="0"/>
           </a:p>
@@ -5189,7 +5565,7 @@
                 <a:ea typeface="Courier New" pitchFamily="34" charset="-122"/>
                 <a:cs typeface="Courier New" pitchFamily="34" charset="-120"/>
               </a:rPr>
-              <a:t>dq_validate findings:  ade7b1f24789740aa19355c0...</a:t>
+              <a:t>dq_validate findings:  b422f2ebd2aad9b20e122af7...</a:t>
             </a:r>
             <a:endParaRPr lang="en-US" sz="1300" dirty="0"/>
           </a:p>
@@ -5228,7 +5604,7 @@
                 <a:ea typeface="Courier New" pitchFamily="34" charset="-122"/>
                 <a:cs typeface="Courier New" pitchFamily="34" charset="-120"/>
               </a:rPr>
-              <a:t>baseline findings:    2e7a710a26705b3b75b04bc5...</a:t>
+              <a:t>baseline findings:    32a8b0ba55be097273b3a915...</a:t>
             </a:r>
             <a:endParaRPr lang="en-US" sz="1300" dirty="0"/>
           </a:p>

</xml_diff>